<commit_message>
grant package: team licences and credentials from hightechmortgage.com/about (DRE 01106294, NMLS 291547, PRC 0024025, CPA, MIT AI/data-science program), LinkedIn reference
Co-Authored-By: Claude Fable 5.1 <noreply@anthropic.com>
Claude-Session: https://claude.ai/code/session_01YTq7uaMnXTpa318aSx8TXi
</commit_message>
<xml_diff>
--- a/docs/grant-deck-2026-09-10.pptx
+++ b/docs/grant-deck-2026-09-10.pptx
@@ -6379,7 +6379,7 @@
                 </a:solidFill>
                 <a:latin typeface="Calibri"/>
               </a:rPr>
-              <a:t>Founder, President, Lead Broker · DRE #01106294</a:t>
+              <a:t>Founder, President, Lead Broker · CA DRE Broker #01106294 · NMLS #291547</a:t>
             </a:r>
           </a:p>
         </p:txBody>
@@ -6473,7 +6473,7 @@
                 </a:solidFill>
                 <a:latin typeface="Calibri"/>
               </a:rPr>
-              <a:t>Data Science, AI and Blockchain · built v2.0</a:t>
+              <a:t>Data Science, AI, Blockchain · MIT post-grad AI/data science · financial-industry data scientist · built v2.0</a:t>
             </a:r>
           </a:p>
         </p:txBody>
@@ -6567,7 +6567,7 @@
                 </a:solidFill>
                 <a:latin typeface="Calibri"/>
               </a:rPr>
-              <a:t>Real Estate, Finance, Philippine Operations · PRC 0024025</a:t>
+              <a:t>Real Estate, Finance, PH Operations · US Realtor · PH Broker PRC 0024025 · CPA</a:t>
             </a:r>
           </a:p>
         </p:txBody>

</xml_diff>

<commit_message>
grant package: full team profiles from hightechmortgage.com/about for all four people (proposal §10, deck team slide + ask slide, TEAM.md v2 wording), LinkedIn reference for Dr Van Wilson
Co-Authored-By: Claude Fable 5.1 <noreply@anthropic.com>
Claude-Session: https://claude.ai/code/session_01YTq7uaMnXTpa318aSx8TXi
</commit_message>
<xml_diff>
--- a/docs/grant-deck-2026-09-10.pptx
+++ b/docs/grant-deck-2026-09-10.pptx
@@ -19,6 +19,7 @@
     <p:sldId id="267" r:id="rId18"/>
     <p:sldId id="268" r:id="rId19"/>
     <p:sldId id="269" r:id="rId20"/>
+    <p:sldId id="270" r:id="rId21"/>
   </p:sldIdLst>
   <p:sldSz cx="12191695" cy="6858000" type="screen4x3"/>
   <p:notesSz cx="6858000" cy="9144000"/>
@@ -6171,7 +6172,7 @@
                 </a:solidFill>
                 <a:latin typeface="Calibri"/>
               </a:rPr>
-              <a:t>Team and the ask</a:t>
+              <a:t>Team (as published at hightechmortgage.com/about)</a:t>
             </a:r>
           </a:p>
         </p:txBody>
@@ -6290,9 +6291,53 @@
           </a:p>
         </p:txBody>
       </p:sp>
+      <p:sp>
+        <p:nvSpPr>
+          <p:cNvPr id="7" name="Rectangle 6"/>
+          <p:cNvSpPr/>
+          <p:nvPr/>
+        </p:nvSpPr>
+        <p:spPr>
+          <a:xfrm>
+            <a:off x="365760" y="1188720"/>
+            <a:ext cx="2788920" cy="5212080"/>
+          </a:xfrm>
+          <a:prstGeom prst="rect">
+            <a:avLst/>
+          </a:prstGeom>
+          <a:solidFill>
+            <a:srgbClr val="F3F5F8"/>
+          </a:solidFill>
+          <a:ln>
+            <a:noFill/>
+          </a:ln>
+          <a:effectLst/>
+        </p:spPr>
+        <p:style>
+          <a:lnRef idx="1">
+            <a:schemeClr val="accent1"/>
+          </a:lnRef>
+          <a:fillRef idx="3">
+            <a:schemeClr val="accent1"/>
+          </a:fillRef>
+          <a:effectRef idx="2">
+            <a:schemeClr val="accent1"/>
+          </a:effectRef>
+          <a:fontRef idx="minor">
+            <a:schemeClr val="lt1"/>
+          </a:fontRef>
+        </p:style>
+        <p:txBody>
+          <a:bodyPr rtlCol="0" anchor="ctr"/>
+          <a:lstStyle/>
+          <a:p>
+            <a:pPr algn="ctr"/>
+          </a:p>
+        </p:txBody>
+      </p:sp>
       <p:pic>
         <p:nvPicPr>
-          <p:cNvPr id="7" name="Picture 6" descr="rich-young-hightechmortgage.jpg"/>
+          <p:cNvPr id="8" name="Picture 7" descr="rich-young-hightechmortgage.jpg"/>
           <p:cNvPicPr>
             <a:picLocks noChangeAspect="1"/>
           </p:cNvPicPr>
@@ -6306,8 +6351,8 @@
         </p:blipFill>
         <p:spPr>
           <a:xfrm>
-            <a:off x="457200" y="1280160"/>
-            <a:ext cx="1272480" cy="1737360"/>
+            <a:off x="502920" y="1325880"/>
+            <a:ext cx="1071562" cy="1463040"/>
           </a:xfrm>
           <a:prstGeom prst="rect">
             <a:avLst/>
@@ -6316,14 +6361,14 @@
       </p:pic>
       <p:sp>
         <p:nvSpPr>
-          <p:cNvPr id="8" name="TextBox 7"/>
+          <p:cNvPr id="9" name="TextBox 8"/>
           <p:cNvSpPr txBox="1"/>
           <p:nvPr/>
         </p:nvSpPr>
         <p:spPr>
           <a:xfrm>
-            <a:off x="457200" y="3063240"/>
-            <a:ext cx="2743200" cy="365760"/>
+            <a:off x="502920" y="2834640"/>
+            <a:ext cx="2560320" cy="320040"/>
           </a:xfrm>
           <a:prstGeom prst="rect">
             <a:avLst/>
@@ -6338,7 +6383,7 @@
           <a:p>
             <a:pPr algn="l"/>
             <a:r>
-              <a:rPr sz="1400" b="1">
+              <a:rPr sz="1500" b="1">
                 <a:solidFill>
                   <a:srgbClr val="0B2545"/>
                 </a:solidFill>
@@ -6351,14 +6396,14 @@
       </p:sp>
       <p:sp>
         <p:nvSpPr>
-          <p:cNvPr id="9" name="TextBox 8"/>
+          <p:cNvPr id="10" name="TextBox 9"/>
           <p:cNvSpPr txBox="1"/>
           <p:nvPr/>
         </p:nvSpPr>
         <p:spPr>
           <a:xfrm>
-            <a:off x="457200" y="3383280"/>
-            <a:ext cx="2743200" cy="731520"/>
+            <a:off x="502920" y="3127248"/>
+            <a:ext cx="2560320" cy="457200"/>
           </a:xfrm>
           <a:prstGeom prst="rect">
             <a:avLst/>
@@ -6373,20 +6418,151 @@
           <a:p>
             <a:pPr algn="l"/>
             <a:r>
-              <a:rPr sz="1100" b="0">
+              <a:rPr sz="1100" b="1">
+                <a:solidFill>
+                  <a:srgbClr val="135BA6"/>
+                </a:solidFill>
+                <a:latin typeface="Calibri"/>
+              </a:rPr>
+              <a:t>Founder, President and Lead Broker</a:t>
+            </a:r>
+          </a:p>
+        </p:txBody>
+      </p:sp>
+      <p:sp>
+        <p:nvSpPr>
+          <p:cNvPr id="11" name="TextBox 10"/>
+          <p:cNvSpPr txBox="1"/>
+          <p:nvPr/>
+        </p:nvSpPr>
+        <p:spPr>
+          <a:xfrm>
+            <a:off x="502920" y="3611880"/>
+            <a:ext cx="2560320" cy="2743200"/>
+          </a:xfrm>
+          <a:prstGeom prst="rect">
+            <a:avLst/>
+          </a:prstGeom>
+          <a:noFill/>
+        </p:spPr>
+        <p:txBody>
+          <a:bodyPr wrap="square">
+            <a:spAutoFit/>
+          </a:bodyPr>
+          <a:lstStyle/>
+          <a:p>
+            <a:pPr>
+              <a:spcAft>
+                <a:spcPts val="300"/>
+              </a:spcAft>
+            </a:pPr>
+            <a:r>
+              <a:rPr sz="1000">
                 <a:solidFill>
                   <a:srgbClr val="555F6B"/>
                 </a:solidFill>
                 <a:latin typeface="Calibri"/>
               </a:rPr>
-              <a:t>Founder, President, Lead Broker · CA DRE Broker #01106294 · NMLS #291547</a:t>
-            </a:r>
+              <a:t>•  California DRE Broker's License #01106294</a:t>
+            </a:r>
+          </a:p>
+          <a:p>
+            <a:pPr>
+              <a:spcAft>
+                <a:spcPts val="300"/>
+              </a:spcAft>
+            </a:pPr>
+            <a:r>
+              <a:rPr sz="1000">
+                <a:solidFill>
+                  <a:srgbClr val="555F6B"/>
+                </a:solidFill>
+                <a:latin typeface="Calibri"/>
+              </a:rPr>
+              <a:t>•  California Mortgage Broker NMLS #291547</a:t>
+            </a:r>
+          </a:p>
+          <a:p>
+            <a:pPr>
+              <a:spcAft>
+                <a:spcPts val="300"/>
+              </a:spcAft>
+            </a:pPr>
+            <a:r>
+              <a:rPr sz="1000">
+                <a:solidFill>
+                  <a:srgbClr val="555F6B"/>
+                </a:solidFill>
+                <a:latin typeface="Calibri"/>
+              </a:rPr>
+              <a:t>•  30+ years Bay Area real estate and mortgage</a:t>
+            </a:r>
+          </a:p>
+          <a:p>
+            <a:pPr>
+              <a:spcAft>
+                <a:spcPts val="300"/>
+              </a:spcAft>
+            </a:pPr>
+            <a:r>
+              <a:rPr sz="1000">
+                <a:solidFill>
+                  <a:srgbClr val="555F6B"/>
+                </a:solidFill>
+                <a:latin typeface="Calibri"/>
+              </a:rPr>
+              <a:t>•  Owns origination, servicing and compliance obligations; licensed principal in both operating models</a:t>
+            </a:r>
+          </a:p>
+        </p:txBody>
+      </p:sp>
+      <p:sp>
+        <p:nvSpPr>
+          <p:cNvPr id="12" name="Rectangle 11"/>
+          <p:cNvSpPr/>
+          <p:nvPr/>
+        </p:nvSpPr>
+        <p:spPr>
+          <a:xfrm>
+            <a:off x="3246120" y="1188720"/>
+            <a:ext cx="2788920" cy="5212080"/>
+          </a:xfrm>
+          <a:prstGeom prst="rect">
+            <a:avLst/>
+          </a:prstGeom>
+          <a:solidFill>
+            <a:srgbClr val="F3F5F8"/>
+          </a:solidFill>
+          <a:ln>
+            <a:noFill/>
+          </a:ln>
+          <a:effectLst/>
+        </p:spPr>
+        <p:style>
+          <a:lnRef idx="1">
+            <a:schemeClr val="accent1"/>
+          </a:lnRef>
+          <a:fillRef idx="3">
+            <a:schemeClr val="accent1"/>
+          </a:fillRef>
+          <a:effectRef idx="2">
+            <a:schemeClr val="accent1"/>
+          </a:effectRef>
+          <a:fontRef idx="minor">
+            <a:schemeClr val="lt1"/>
+          </a:fontRef>
+        </p:style>
+        <p:txBody>
+          <a:bodyPr rtlCol="0" anchor="ctr"/>
+          <a:lstStyle/>
+          <a:p>
+            <a:pPr algn="ctr"/>
           </a:p>
         </p:txBody>
       </p:sp>
       <p:pic>
         <p:nvPicPr>
-          <p:cNvPr id="10" name="Picture 9" descr="van-wilson-hightechmortgage.png"/>
+          <p:cNvPr id="13" name="Picture 12" descr="van-wilson-hightechmortgage.png"/>
           <p:cNvPicPr>
             <a:picLocks noChangeAspect="1"/>
           </p:cNvPicPr>
@@ -6400,8 +6576,8 @@
         </p:blipFill>
         <p:spPr>
           <a:xfrm>
-            <a:off x="3337560" y="1280160"/>
-            <a:ext cx="1887347" cy="1737360"/>
+            <a:off x="3383280" y="1325880"/>
+            <a:ext cx="1589345" cy="1463040"/>
           </a:xfrm>
           <a:prstGeom prst="rect">
             <a:avLst/>
@@ -6410,14 +6586,14 @@
       </p:pic>
       <p:sp>
         <p:nvSpPr>
-          <p:cNvPr id="11" name="TextBox 10"/>
+          <p:cNvPr id="14" name="TextBox 13"/>
           <p:cNvSpPr txBox="1"/>
           <p:nvPr/>
         </p:nvSpPr>
         <p:spPr>
           <a:xfrm>
-            <a:off x="3337560" y="3063240"/>
-            <a:ext cx="2743200" cy="365760"/>
+            <a:off x="3383280" y="2834640"/>
+            <a:ext cx="2560320" cy="320040"/>
           </a:xfrm>
           <a:prstGeom prst="rect">
             <a:avLst/>
@@ -6432,7 +6608,7 @@
           <a:p>
             <a:pPr algn="l"/>
             <a:r>
-              <a:rPr sz="1400" b="1">
+              <a:rPr sz="1500" b="1">
                 <a:solidFill>
                   <a:srgbClr val="0B2545"/>
                 </a:solidFill>
@@ -6445,14 +6621,14 @@
       </p:sp>
       <p:sp>
         <p:nvSpPr>
-          <p:cNvPr id="12" name="TextBox 11"/>
+          <p:cNvPr id="15" name="TextBox 14"/>
           <p:cNvSpPr txBox="1"/>
           <p:nvPr/>
         </p:nvSpPr>
         <p:spPr>
           <a:xfrm>
-            <a:off x="3337560" y="3383280"/>
-            <a:ext cx="2743200" cy="731520"/>
+            <a:off x="3383280" y="3127248"/>
+            <a:ext cx="2560320" cy="457200"/>
           </a:xfrm>
           <a:prstGeom prst="rect">
             <a:avLst/>
@@ -6467,20 +6643,167 @@
           <a:p>
             <a:pPr algn="l"/>
             <a:r>
-              <a:rPr sz="1100" b="0">
+              <a:rPr sz="1100" b="1">
+                <a:solidFill>
+                  <a:srgbClr val="135BA6"/>
+                </a:solidFill>
+                <a:latin typeface="Calibri"/>
+              </a:rPr>
+              <a:t>Data Science, AI and Blockchain</a:t>
+            </a:r>
+          </a:p>
+        </p:txBody>
+      </p:sp>
+      <p:sp>
+        <p:nvSpPr>
+          <p:cNvPr id="16" name="TextBox 15"/>
+          <p:cNvSpPr txBox="1"/>
+          <p:nvPr/>
+        </p:nvSpPr>
+        <p:spPr>
+          <a:xfrm>
+            <a:off x="3383280" y="3611880"/>
+            <a:ext cx="2560320" cy="2743200"/>
+          </a:xfrm>
+          <a:prstGeom prst="rect">
+            <a:avLst/>
+          </a:prstGeom>
+          <a:noFill/>
+        </p:spPr>
+        <p:txBody>
+          <a:bodyPr wrap="square">
+            <a:spAutoFit/>
+          </a:bodyPr>
+          <a:lstStyle/>
+          <a:p>
+            <a:pPr>
+              <a:spcAft>
+                <a:spcPts val="300"/>
+              </a:spcAft>
+            </a:pPr>
+            <a:r>
+              <a:rPr sz="1000">
                 <a:solidFill>
                   <a:srgbClr val="555F6B"/>
                 </a:solidFill>
                 <a:latin typeface="Calibri"/>
               </a:rPr>
-              <a:t>Data Science, AI, Blockchain · MIT post-grad AI/data science · financial-industry data scientist · built v2.0</a:t>
-            </a:r>
+              <a:t>•  MIT post-graduate program, AI and data science; CSU Fullerton BS</a:t>
+            </a:r>
+          </a:p>
+          <a:p>
+            <a:pPr>
+              <a:spcAft>
+                <a:spcPts val="300"/>
+              </a:spcAft>
+            </a:pPr>
+            <a:r>
+              <a:rPr sz="1000">
+                <a:solidFill>
+                  <a:srgbClr val="555F6B"/>
+                </a:solidFill>
+                <a:latin typeface="Calibri"/>
+              </a:rPr>
+              <a:t>•  AWS Certified Developer; Databricks; Blockchain Training Alliance; Microsoft Certified Trainer</a:t>
+            </a:r>
+          </a:p>
+          <a:p>
+            <a:pPr>
+              <a:spcAft>
+                <a:spcPts val="300"/>
+              </a:spcAft>
+            </a:pPr>
+            <a:r>
+              <a:rPr sz="1000">
+                <a:solidFill>
+                  <a:srgbClr val="555F6B"/>
+                </a:solidFill>
+                <a:latin typeface="Calibri"/>
+              </a:rPr>
+              <a:t>•  Certified PostgreSQL / SQL Server / MySQL DBA; Sage, QuickBooks, MS NAV</a:t>
+            </a:r>
+          </a:p>
+          <a:p>
+            <a:pPr>
+              <a:spcAft>
+                <a:spcPts val="300"/>
+              </a:spcAft>
+            </a:pPr>
+            <a:r>
+              <a:rPr sz="1000">
+                <a:solidFill>
+                  <a:srgbClr val="555F6B"/>
+                </a:solidFill>
+                <a:latin typeface="Calibri"/>
+              </a:rPr>
+              <a:t>•  35 years real-estate investor, $10M+ portfolio; financial-industry data scientist; built v2.0</a:t>
+            </a:r>
+          </a:p>
+          <a:p>
+            <a:pPr>
+              <a:spcAft>
+                <a:spcPts val="300"/>
+              </a:spcAft>
+            </a:pPr>
+            <a:r>
+              <a:rPr sz="1000">
+                <a:solidFill>
+                  <a:srgbClr val="555F6B"/>
+                </a:solidFill>
+                <a:latin typeface="Calibri"/>
+              </a:rPr>
+              <a:t>•  linkedin.com/in/drvanwilson</a:t>
+            </a:r>
+          </a:p>
+        </p:txBody>
+      </p:sp>
+      <p:sp>
+        <p:nvSpPr>
+          <p:cNvPr id="17" name="Rectangle 16"/>
+          <p:cNvSpPr/>
+          <p:nvPr/>
+        </p:nvSpPr>
+        <p:spPr>
+          <a:xfrm>
+            <a:off x="6126480" y="1188720"/>
+            <a:ext cx="2788920" cy="5212080"/>
+          </a:xfrm>
+          <a:prstGeom prst="rect">
+            <a:avLst/>
+          </a:prstGeom>
+          <a:solidFill>
+            <a:srgbClr val="F3F5F8"/>
+          </a:solidFill>
+          <a:ln>
+            <a:noFill/>
+          </a:ln>
+          <a:effectLst/>
+        </p:spPr>
+        <p:style>
+          <a:lnRef idx="1">
+            <a:schemeClr val="accent1"/>
+          </a:lnRef>
+          <a:fillRef idx="3">
+            <a:schemeClr val="accent1"/>
+          </a:fillRef>
+          <a:effectRef idx="2">
+            <a:schemeClr val="accent1"/>
+          </a:effectRef>
+          <a:fontRef idx="minor">
+            <a:schemeClr val="lt1"/>
+          </a:fontRef>
+        </p:style>
+        <p:txBody>
+          <a:bodyPr rtlCol="0" anchor="ctr"/>
+          <a:lstStyle/>
+          <a:p>
+            <a:pPr algn="ctr"/>
           </a:p>
         </p:txBody>
       </p:sp>
       <p:pic>
         <p:nvPicPr>
-          <p:cNvPr id="13" name="Picture 12" descr="trish-wilson-hightechmortgage.jpeg"/>
+          <p:cNvPr id="18" name="Picture 17" descr="trish-wilson-hightechmortgage.jpeg"/>
           <p:cNvPicPr>
             <a:picLocks noChangeAspect="1"/>
           </p:cNvPicPr>
@@ -6494,8 +6817,8 @@
         </p:blipFill>
         <p:spPr>
           <a:xfrm>
-            <a:off x="6217920" y="1280160"/>
-            <a:ext cx="1617850" cy="1737360"/>
+            <a:off x="6263640" y="1325880"/>
+            <a:ext cx="1362400" cy="1463040"/>
           </a:xfrm>
           <a:prstGeom prst="rect">
             <a:avLst/>
@@ -6504,14 +6827,14 @@
       </p:pic>
       <p:sp>
         <p:nvSpPr>
-          <p:cNvPr id="14" name="TextBox 13"/>
+          <p:cNvPr id="19" name="TextBox 18"/>
           <p:cNvSpPr txBox="1"/>
           <p:nvPr/>
         </p:nvSpPr>
         <p:spPr>
           <a:xfrm>
-            <a:off x="6217920" y="3063240"/>
-            <a:ext cx="2743200" cy="365760"/>
+            <a:off x="6263640" y="2834640"/>
+            <a:ext cx="2560320" cy="320040"/>
           </a:xfrm>
           <a:prstGeom prst="rect">
             <a:avLst/>
@@ -6526,7 +6849,7 @@
           <a:p>
             <a:pPr algn="l"/>
             <a:r>
-              <a:rPr sz="1400" b="1">
+              <a:rPr sz="1500" b="1">
                 <a:solidFill>
                   <a:srgbClr val="0B2545"/>
                 </a:solidFill>
@@ -6539,14 +6862,14 @@
       </p:sp>
       <p:sp>
         <p:nvSpPr>
-          <p:cNvPr id="15" name="TextBox 14"/>
+          <p:cNvPr id="20" name="TextBox 19"/>
           <p:cNvSpPr txBox="1"/>
           <p:nvPr/>
         </p:nvSpPr>
         <p:spPr>
           <a:xfrm>
-            <a:off x="6217920" y="3383280"/>
-            <a:ext cx="2743200" cy="731520"/>
+            <a:off x="6263640" y="3127248"/>
+            <a:ext cx="2560320" cy="457200"/>
           </a:xfrm>
           <a:prstGeom prst="rect">
             <a:avLst/>
@@ -6561,20 +6884,151 @@
           <a:p>
             <a:pPr algn="l"/>
             <a:r>
-              <a:rPr sz="1100" b="0">
+              <a:rPr sz="1100" b="1">
+                <a:solidFill>
+                  <a:srgbClr val="135BA6"/>
+                </a:solidFill>
+                <a:latin typeface="Calibri"/>
+              </a:rPr>
+              <a:t>Real Estate, Finance and PH Operations</a:t>
+            </a:r>
+          </a:p>
+        </p:txBody>
+      </p:sp>
+      <p:sp>
+        <p:nvSpPr>
+          <p:cNvPr id="21" name="TextBox 20"/>
+          <p:cNvSpPr txBox="1"/>
+          <p:nvPr/>
+        </p:nvSpPr>
+        <p:spPr>
+          <a:xfrm>
+            <a:off x="6263640" y="3611880"/>
+            <a:ext cx="2560320" cy="2743200"/>
+          </a:xfrm>
+          <a:prstGeom prst="rect">
+            <a:avLst/>
+          </a:prstGeom>
+          <a:noFill/>
+        </p:spPr>
+        <p:txBody>
+          <a:bodyPr wrap="square">
+            <a:spAutoFit/>
+          </a:bodyPr>
+          <a:lstStyle/>
+          <a:p>
+            <a:pPr>
+              <a:spcAft>
+                <a:spcPts val="300"/>
+              </a:spcAft>
+            </a:pPr>
+            <a:r>
+              <a:rPr sz="1000">
                 <a:solidFill>
                   <a:srgbClr val="555F6B"/>
                 </a:solidFill>
                 <a:latin typeface="Calibri"/>
               </a:rPr>
-              <a:t>Real Estate, Finance, PH Operations · US Realtor · PH Broker PRC 0024025 · CPA</a:t>
-            </a:r>
+              <a:t>•  Active licensed US Realtor</a:t>
+            </a:r>
+          </a:p>
+          <a:p>
+            <a:pPr>
+              <a:spcAft>
+                <a:spcPts val="300"/>
+              </a:spcAft>
+            </a:pPr>
+            <a:r>
+              <a:rPr sz="1000">
+                <a:solidFill>
+                  <a:srgbClr val="555F6B"/>
+                </a:solidFill>
+                <a:latin typeface="Calibri"/>
+              </a:rPr>
+              <a:t>•  Philippine Real Estate Broker PRC 0024025</a:t>
+            </a:r>
+          </a:p>
+          <a:p>
+            <a:pPr>
+              <a:spcAft>
+                <a:spcPts val="300"/>
+              </a:spcAft>
+            </a:pPr>
+            <a:r>
+              <a:rPr sz="1000">
+                <a:solidFill>
+                  <a:srgbClr val="555F6B"/>
+                </a:solidFill>
+                <a:latin typeface="Calibri"/>
+              </a:rPr>
+              <a:t>•  CPA (St. Paul University, BA Accounting); Int'l Certified Financial Consultant; ex-internal auditor, Philippine Airlines</a:t>
+            </a:r>
+          </a:p>
+          <a:p>
+            <a:pPr>
+              <a:spcAft>
+                <a:spcPts val="300"/>
+              </a:spcAft>
+            </a:pPr>
+            <a:r>
+              <a:rPr sz="1000">
+                <a:solidFill>
+                  <a:srgbClr val="555F6B"/>
+                </a:solidFill>
+                <a:latin typeface="Calibri"/>
+              </a:rPr>
+              <a:t>•  Leads Manila servicing operations under dual control; accounting review</a:t>
+            </a:r>
+          </a:p>
+        </p:txBody>
+      </p:sp>
+      <p:sp>
+        <p:nvSpPr>
+          <p:cNvPr id="22" name="Rectangle 21"/>
+          <p:cNvSpPr/>
+          <p:nvPr/>
+        </p:nvSpPr>
+        <p:spPr>
+          <a:xfrm>
+            <a:off x="9006840" y="1188720"/>
+            <a:ext cx="2788920" cy="5212080"/>
+          </a:xfrm>
+          <a:prstGeom prst="rect">
+            <a:avLst/>
+          </a:prstGeom>
+          <a:solidFill>
+            <a:srgbClr val="F3F5F8"/>
+          </a:solidFill>
+          <a:ln>
+            <a:noFill/>
+          </a:ln>
+          <a:effectLst/>
+        </p:spPr>
+        <p:style>
+          <a:lnRef idx="1">
+            <a:schemeClr val="accent1"/>
+          </a:lnRef>
+          <a:fillRef idx="3">
+            <a:schemeClr val="accent1"/>
+          </a:fillRef>
+          <a:effectRef idx="2">
+            <a:schemeClr val="accent1"/>
+          </a:effectRef>
+          <a:fontRef idx="minor">
+            <a:schemeClr val="lt1"/>
+          </a:fontRef>
+        </p:style>
+        <p:txBody>
+          <a:bodyPr rtlCol="0" anchor="ctr"/>
+          <a:lstStyle/>
+          <a:p>
+            <a:pPr algn="ctr"/>
           </a:p>
         </p:txBody>
       </p:sp>
       <p:pic>
         <p:nvPicPr>
-          <p:cNvPr id="16" name="Picture 15" descr="bill-thompson-hightechmortgage.jpg"/>
+          <p:cNvPr id="23" name="Picture 22" descr="bill-thompson-hightechmortgage.jpg"/>
           <p:cNvPicPr>
             <a:picLocks noChangeAspect="1"/>
           </p:cNvPicPr>
@@ -6588,8 +7042,8 @@
         </p:blipFill>
         <p:spPr>
           <a:xfrm>
-            <a:off x="9098280" y="1280160"/>
-            <a:ext cx="1737360" cy="1737360"/>
+            <a:off x="9144000" y="1325880"/>
+            <a:ext cx="1463040" cy="1463040"/>
           </a:xfrm>
           <a:prstGeom prst="rect">
             <a:avLst/>
@@ -6598,14 +7052,14 @@
       </p:pic>
       <p:sp>
         <p:nvSpPr>
-          <p:cNvPr id="17" name="TextBox 16"/>
+          <p:cNvPr id="24" name="TextBox 23"/>
           <p:cNvSpPr txBox="1"/>
           <p:nvPr/>
         </p:nvSpPr>
         <p:spPr>
           <a:xfrm>
-            <a:off x="9098280" y="3063240"/>
-            <a:ext cx="2743200" cy="365760"/>
+            <a:off x="9144000" y="2834640"/>
+            <a:ext cx="2560320" cy="320040"/>
           </a:xfrm>
           <a:prstGeom prst="rect">
             <a:avLst/>
@@ -6620,7 +7074,7 @@
           <a:p>
             <a:pPr algn="l"/>
             <a:r>
-              <a:rPr sz="1400" b="1">
+              <a:rPr sz="1500" b="1">
                 <a:solidFill>
                   <a:srgbClr val="0B2545"/>
                 </a:solidFill>
@@ -6633,14 +7087,14 @@
       </p:sp>
       <p:sp>
         <p:nvSpPr>
-          <p:cNvPr id="18" name="TextBox 17"/>
+          <p:cNvPr id="25" name="TextBox 24"/>
           <p:cNvSpPr txBox="1"/>
           <p:nvPr/>
         </p:nvSpPr>
         <p:spPr>
           <a:xfrm>
-            <a:off x="9098280" y="3383280"/>
-            <a:ext cx="2743200" cy="731520"/>
+            <a:off x="9144000" y="3127248"/>
+            <a:ext cx="2560320" cy="457200"/>
           </a:xfrm>
           <a:prstGeom prst="rect">
             <a:avLst/>
@@ -6655,27 +7109,246 @@
           <a:p>
             <a:pPr algn="l"/>
             <a:r>
-              <a:rPr sz="1100" b="0">
+              <a:rPr sz="1100" b="1">
+                <a:solidFill>
+                  <a:srgbClr val="135BA6"/>
+                </a:solidFill>
+                <a:latin typeface="Calibri"/>
+              </a:rPr>
+              <a:t>Operations, IT and Business Management</a:t>
+            </a:r>
+          </a:p>
+        </p:txBody>
+      </p:sp>
+      <p:sp>
+        <p:nvSpPr>
+          <p:cNvPr id="26" name="TextBox 25"/>
+          <p:cNvSpPr txBox="1"/>
+          <p:nvPr/>
+        </p:nvSpPr>
+        <p:spPr>
+          <a:xfrm>
+            <a:off x="9144000" y="3611880"/>
+            <a:ext cx="2560320" cy="2743200"/>
+          </a:xfrm>
+          <a:prstGeom prst="rect">
+            <a:avLst/>
+          </a:prstGeom>
+          <a:noFill/>
+        </p:spPr>
+        <p:txBody>
+          <a:bodyPr wrap="square">
+            <a:spAutoFit/>
+          </a:bodyPr>
+          <a:lstStyle/>
+          <a:p>
+            <a:pPr>
+              <a:spcAft>
+                <a:spcPts val="300"/>
+              </a:spcAft>
+            </a:pPr>
+            <a:r>
+              <a:rPr sz="1000">
                 <a:solidFill>
                   <a:srgbClr val="555F6B"/>
                 </a:solidFill>
                 <a:latin typeface="Calibri"/>
               </a:rPr>
-              <a:t>Operations, IT, Business Management</a:t>
-            </a:r>
-          </a:p>
-        </p:txBody>
-      </p:sp>
-      <p:sp>
-        <p:nvSpPr>
-          <p:cNvPr id="19" name="Rectangle 18"/>
+              <a:t>•  ITIL v4; Six Sigma Quality; CompTIA A+; TOPCIT</a:t>
+            </a:r>
+          </a:p>
+          <a:p>
+            <a:pPr>
+              <a:spcAft>
+                <a:spcPts val="300"/>
+              </a:spcAft>
+            </a:pPr>
+            <a:r>
+              <a:rPr sz="1000">
+                <a:solidFill>
+                  <a:srgbClr val="555F6B"/>
+                </a:solidFill>
+                <a:latin typeface="Calibri"/>
+              </a:rPr>
+              <a:t>•  Practical Project Mgmt; URAC; FranklinCovey Mgmt</a:t>
+            </a:r>
+          </a:p>
+          <a:p>
+            <a:pPr>
+              <a:spcAft>
+                <a:spcPts val="300"/>
+              </a:spcAft>
+            </a:pPr>
+            <a:r>
+              <a:rPr sz="1000">
+                <a:solidFill>
+                  <a:srgbClr val="555F6B"/>
+                </a:solidFill>
+                <a:latin typeface="Calibri"/>
+              </a:rPr>
+              <a:t>•  Ateneo Graduate School of Business; CSU Dominguez Hills</a:t>
+            </a:r>
+          </a:p>
+          <a:p>
+            <a:pPr>
+              <a:spcAft>
+                <a:spcPts val="300"/>
+              </a:spcAft>
+            </a:pPr>
+            <a:r>
+              <a:rPr sz="1000">
+                <a:solidFill>
+                  <a:srgbClr val="555F6B"/>
+                </a:solidFill>
+                <a:latin typeface="Calibri"/>
+              </a:rPr>
+              <a:t>•  Operations, infrastructure and process discipline; dual-control task queue</a:t>
+            </a:r>
+          </a:p>
+        </p:txBody>
+      </p:sp>
+    </p:spTree>
+  </p:cSld>
+  <p:clrMapOvr>
+    <a:masterClrMapping/>
+  </p:clrMapOvr>
+</p:sld>
+</file>
+
+<file path=ppt/slides/slide15.xml><?xml version="1.0" encoding="utf-8"?>
+<p:sld xmlns:a="http://schemas.openxmlformats.org/drawingml/2006/main" xmlns:p="http://schemas.openxmlformats.org/presentationml/2006/main" xmlns:r="http://schemas.openxmlformats.org/officeDocument/2006/relationships">
+  <p:cSld>
+    <p:spTree>
+      <p:nvGrpSpPr>
+        <p:cNvPr id="1" name=""/>
+        <p:cNvGrpSpPr/>
+        <p:nvPr/>
+      </p:nvGrpSpPr>
+      <p:grpSpPr/>
+      <p:sp>
+        <p:nvSpPr>
+          <p:cNvPr id="2" name="Rectangle 1"/>
           <p:cNvSpPr/>
           <p:nvPr/>
         </p:nvSpPr>
         <p:spPr>
           <a:xfrm>
-            <a:off x="457200" y="4297680"/>
-            <a:ext cx="11247120" cy="1737360"/>
+            <a:off x="0" y="0"/>
+            <a:ext cx="12191695" cy="960120"/>
+          </a:xfrm>
+          <a:prstGeom prst="rect">
+            <a:avLst/>
+          </a:prstGeom>
+          <a:solidFill>
+            <a:srgbClr val="0B2545"/>
+          </a:solidFill>
+          <a:ln>
+            <a:noFill/>
+          </a:ln>
+          <a:effectLst/>
+        </p:spPr>
+        <p:style>
+          <a:lnRef idx="1">
+            <a:schemeClr val="accent1"/>
+          </a:lnRef>
+          <a:fillRef idx="3">
+            <a:schemeClr val="accent1"/>
+          </a:fillRef>
+          <a:effectRef idx="2">
+            <a:schemeClr val="accent1"/>
+          </a:effectRef>
+          <a:fontRef idx="minor">
+            <a:schemeClr val="lt1"/>
+          </a:fontRef>
+        </p:style>
+        <p:txBody>
+          <a:bodyPr rtlCol="0" anchor="ctr"/>
+          <a:lstStyle/>
+          <a:p>
+            <a:pPr algn="ctr"/>
+          </a:p>
+        </p:txBody>
+      </p:sp>
+      <p:sp>
+        <p:nvSpPr>
+          <p:cNvPr id="3" name="TextBox 2"/>
+          <p:cNvSpPr txBox="1"/>
+          <p:nvPr/>
+        </p:nvSpPr>
+        <p:spPr>
+          <a:xfrm>
+            <a:off x="457200" y="164592"/>
+            <a:ext cx="10515600" cy="731520"/>
+          </a:xfrm>
+          <a:prstGeom prst="rect">
+            <a:avLst/>
+          </a:prstGeom>
+          <a:noFill/>
+        </p:spPr>
+        <p:txBody>
+          <a:bodyPr wrap="square" anchor="ctr">
+            <a:spAutoFit/>
+          </a:bodyPr>
+          <a:lstStyle/>
+          <a:p>
+            <a:pPr algn="l"/>
+            <a:r>
+              <a:rPr sz="2800" b="1">
+                <a:solidFill>
+                  <a:srgbClr val="FFFFFF"/>
+                </a:solidFill>
+                <a:latin typeface="Calibri"/>
+              </a:rPr>
+              <a:t>The ask</a:t>
+            </a:r>
+          </a:p>
+        </p:txBody>
+      </p:sp>
+      <p:sp>
+        <p:nvSpPr>
+          <p:cNvPr id="4" name="TextBox 3"/>
+          <p:cNvSpPr txBox="1"/>
+          <p:nvPr/>
+        </p:nvSpPr>
+        <p:spPr>
+          <a:xfrm>
+            <a:off x="11155680" y="320040"/>
+            <a:ext cx="822960" cy="457200"/>
+          </a:xfrm>
+          <a:prstGeom prst="rect">
+            <a:avLst/>
+          </a:prstGeom>
+          <a:noFill/>
+        </p:spPr>
+        <p:txBody>
+          <a:bodyPr wrap="square" anchor="t">
+            <a:spAutoFit/>
+          </a:bodyPr>
+          <a:lstStyle/>
+          <a:p>
+            <a:pPr algn="r"/>
+            <a:r>
+              <a:rPr sz="1200" b="0">
+                <a:solidFill>
+                  <a:srgbClr val="C99A2E"/>
+                </a:solidFill>
+                <a:latin typeface="Calibri"/>
+              </a:rPr>
+              <a:t>15</a:t>
+            </a:r>
+          </a:p>
+        </p:txBody>
+      </p:sp>
+      <p:sp>
+        <p:nvSpPr>
+          <p:cNvPr id="5" name="Rectangle 4"/>
+          <p:cNvSpPr/>
+          <p:nvPr/>
+        </p:nvSpPr>
+        <p:spPr>
+          <a:xfrm>
+            <a:off x="0" y="6537960"/>
+            <a:ext cx="12191695" cy="320040"/>
           </a:xfrm>
           <a:prstGeom prst="rect">
             <a:avLst/>
@@ -6712,14 +7385,14 @@
       </p:sp>
       <p:sp>
         <p:nvSpPr>
-          <p:cNvPr id="20" name="TextBox 19"/>
+          <p:cNvPr id="6" name="TextBox 5"/>
           <p:cNvSpPr txBox="1"/>
           <p:nvPr/>
         </p:nvSpPr>
         <p:spPr>
           <a:xfrm>
-            <a:off x="640080" y="4389120"/>
-            <a:ext cx="10972800" cy="457200"/>
+            <a:off x="457200" y="6547104"/>
+            <a:ext cx="10972800" cy="274320"/>
           </a:xfrm>
           <a:prstGeom prst="rect">
             <a:avLst/>
@@ -6734,27 +7407,27 @@
           <a:p>
             <a:pPr algn="l"/>
             <a:r>
-              <a:rPr sz="1800" b="1">
-                <a:solidFill>
-                  <a:srgbClr val="135BA6"/>
-                </a:solidFill>
-                <a:latin typeface="Calibri"/>
-              </a:rPr>
-              <a:t>The ask</a:t>
-            </a:r>
-          </a:p>
-        </p:txBody>
-      </p:sp>
-      <p:sp>
-        <p:nvSpPr>
-          <p:cNvPr id="21" name="TextBox 20"/>
+              <a:rPr sz="1000" b="0">
+                <a:solidFill>
+                  <a:srgbClr val="555F6B"/>
+                </a:solidFill>
+                <a:latin typeface="Calibri"/>
+              </a:rPr>
+              <a:t>High Tech Mortgage, Inc. · MortgageOS™ servicing layer v2.0.0 · XRPL Grants proposal · September 10, 2026 · github.com/vanfwilson/xrpl-mortgage-tokenizing-htm</a:t>
+            </a:r>
+          </a:p>
+        </p:txBody>
+      </p:sp>
+      <p:sp>
+        <p:nvSpPr>
+          <p:cNvPr id="7" name="TextBox 6"/>
           <p:cNvSpPr txBox="1"/>
           <p:nvPr/>
         </p:nvSpPr>
         <p:spPr>
           <a:xfrm>
-            <a:off x="640080" y="4846320"/>
-            <a:ext cx="10972800" cy="1188720"/>
+            <a:off x="548640" y="1463040"/>
+            <a:ext cx="10972800" cy="1280160"/>
           </a:xfrm>
           <a:prstGeom prst="rect">
             <a:avLst/>
@@ -6769,25 +7442,163 @@
           <a:p>
             <a:pPr algn="l"/>
             <a:r>
+              <a:rPr sz="2600" b="1">
+                <a:solidFill>
+                  <a:srgbClr val="0B2545"/>
+                </a:solidFill>
+                <a:latin typeface="Calibri"/>
+              </a:rPr>
+              <a:t>$200,000 of milestone-gated funding over 12 months for the plan on slides 11 and 12.</a:t>
+            </a:r>
+          </a:p>
+        </p:txBody>
+      </p:sp>
+      <p:sp>
+        <p:nvSpPr>
+          <p:cNvPr id="8" name="TextBox 7"/>
+          <p:cNvSpPr txBox="1"/>
+          <p:nvPr/>
+        </p:nvSpPr>
+        <p:spPr>
+          <a:xfrm>
+            <a:off x="548640" y="2834640"/>
+            <a:ext cx="10972800" cy="2377440"/>
+          </a:xfrm>
+          <a:prstGeom prst="rect">
+            <a:avLst/>
+          </a:prstGeom>
+          <a:noFill/>
+        </p:spPr>
+        <p:txBody>
+          <a:bodyPr wrap="square">
+            <a:spAutoFit/>
+          </a:bodyPr>
+          <a:lstStyle/>
+          <a:p>
+            <a:pPr>
+              <a:spcAft>
+                <a:spcPts val="600"/>
+              </a:spcAft>
+            </a:pPr>
+            <a:r>
+              <a:rPr sz="1600">
+                <a:solidFill>
+                  <a:srgbClr val="0B2545"/>
+                </a:solidFill>
+                <a:latin typeface="Calibri"/>
+              </a:rPr>
+              <a:t>•  Introductions to banks that outsource servicing operations, and to the RLUSD / institutional team on the custodial-asset question.</a:t>
+            </a:r>
+          </a:p>
+          <a:p>
+            <a:pPr>
+              <a:spcAft>
+                <a:spcPts val="600"/>
+              </a:spcAft>
+            </a:pPr>
+            <a:r>
+              <a:rPr sz="1600">
+                <a:solidFill>
+                  <a:srgbClr val="0B2545"/>
+                </a:solidFill>
+                <a:latin typeface="Calibri"/>
+              </a:rPr>
+              <a:t>•  Everything stays open source: the canonical loan schema, the regulatory control map and its tests, the memo and receipt-file contracts, the evidence-pack format, the cost model.</a:t>
+            </a:r>
+          </a:p>
+          <a:p>
+            <a:pPr>
+              <a:spcAft>
+                <a:spcPts val="600"/>
+              </a:spcAft>
+            </a:pPr>
+            <a:r>
+              <a:rPr sz="1600">
+                <a:solidFill>
+                  <a:srgbClr val="0B2545"/>
+                </a:solidFill>
+                <a:latin typeface="Calibri"/>
+              </a:rPr>
+              <a:t>•  Repository: github.com/vanfwilson/xrpl-mortgage-tokenizing-htm  ·  Live demo: vanfwilson.github.io/xrpl-mortgage-tokenizing-htm/demo  ·  Proposal: docs/grant-proposal-2026-09-10.pdf</a:t>
+            </a:r>
+          </a:p>
+        </p:txBody>
+      </p:sp>
+      <p:sp>
+        <p:nvSpPr>
+          <p:cNvPr id="9" name="Rectangle 8"/>
+          <p:cNvSpPr/>
+          <p:nvPr/>
+        </p:nvSpPr>
+        <p:spPr>
+          <a:xfrm>
+            <a:off x="548640" y="5120640"/>
+            <a:ext cx="10972800" cy="914400"/>
+          </a:xfrm>
+          <a:prstGeom prst="rect">
+            <a:avLst/>
+          </a:prstGeom>
+          <a:solidFill>
+            <a:srgbClr val="F3F5F8"/>
+          </a:solidFill>
+          <a:ln>
+            <a:noFill/>
+          </a:ln>
+          <a:effectLst/>
+        </p:spPr>
+        <p:style>
+          <a:lnRef idx="1">
+            <a:schemeClr val="accent1"/>
+          </a:lnRef>
+          <a:fillRef idx="3">
+            <a:schemeClr val="accent1"/>
+          </a:fillRef>
+          <a:effectRef idx="2">
+            <a:schemeClr val="accent1"/>
+          </a:effectRef>
+          <a:fontRef idx="minor">
+            <a:schemeClr val="lt1"/>
+          </a:fontRef>
+        </p:style>
+        <p:txBody>
+          <a:bodyPr rtlCol="0" anchor="ctr"/>
+          <a:lstStyle/>
+          <a:p>
+            <a:pPr algn="ctr"/>
+          </a:p>
+        </p:txBody>
+      </p:sp>
+      <p:sp>
+        <p:nvSpPr>
+          <p:cNvPr id="10" name="TextBox 9"/>
+          <p:cNvSpPr txBox="1"/>
+          <p:nvPr/>
+        </p:nvSpPr>
+        <p:spPr>
+          <a:xfrm>
+            <a:off x="731520" y="5212080"/>
+            <a:ext cx="10607040" cy="731520"/>
+          </a:xfrm>
+          <a:prstGeom prst="rect">
+            <a:avLst/>
+          </a:prstGeom>
+          <a:noFill/>
+        </p:spPr>
+        <p:txBody>
+          <a:bodyPr wrap="square" anchor="ctr">
+            <a:spAutoFit/>
+          </a:bodyPr>
+          <a:lstStyle/>
+          <a:p>
+            <a:pPr algn="l"/>
+            <a:r>
               <a:rPr sz="1300" b="0">
                 <a:solidFill>
-                  <a:srgbClr val="0B2545"/>
-                </a:solidFill>
-                <a:latin typeface="Calibri"/>
-              </a:rPr>
-              <a:t>$200,000 of milestone-gated funding for the plan above, plus introductions to banks that outsource servicing operations and to the RLUSD / institutional team on the custodial-asset question.</a:t>
-            </a:r>
-          </a:p>
-          <a:p>
-            <a:pPr algn="l"/>
-            <a:r>
-              <a:rPr sz="1300" b="0">
-                <a:solidFill>
-                  <a:srgbClr val="0B2545"/>
-                </a:solidFill>
-                <a:latin typeface="Calibri"/>
-              </a:rPr>
-              <a:t>Repository: github.com/vanfwilson/xrpl-mortgage-tokenizing-htm · Demo: vanfwilson.github.io/xrpl-mortgage-tokenizing-htm/demo · Proposal: docs/grant-proposal-2026-09-10.pdf</a:t>
+                  <a:srgbClr val="555F6B"/>
+                </a:solidFill>
+                <a:latin typeface="Calibri"/>
+              </a:rPr>
+              <a:t>High Tech Mortgage, Inc. · 730 I Street, Sacramento, CA 95814 · 19F Marco Polo Ortigas, Pasig City, Metro Manila · info@hightechmortgage.com</a:t>
             </a:r>
           </a:p>
         </p:txBody>

</xml_diff>

<commit_message>
team: Dr Van Wilson formerly with the U.S. SEC and Fannie Mae (work history, leads the profile)
Co-Authored-By: Claude Fable 5.1 <noreply@anthropic.com>
Claude-Session: https://claude.ai/code/session_01YTq7uaMnXTpa318aSx8TXi
</commit_message>
<xml_diff>
--- a/docs/grant-deck-2026-09-10.pptx
+++ b/docs/grant-deck-2026-09-10.pptx
@@ -6688,7 +6688,7 @@
                 </a:solidFill>
                 <a:latin typeface="Calibri"/>
               </a:rPr>
-              <a:t>•  MIT post-graduate program, AI and data science; CSU Fullerton BS</a:t>
+              <a:t>•  Formerly U.S. Securities and Exchange Commission (SEC) and Fannie Mae</a:t>
             </a:r>
           </a:p>
           <a:p>
@@ -6704,7 +6704,7 @@
                 </a:solidFill>
                 <a:latin typeface="Calibri"/>
               </a:rPr>
-              <a:t>•  AWS Certified Developer; Databricks; Blockchain Training Alliance; Microsoft Certified Trainer</a:t>
+              <a:t>•  MIT post-graduate program, AI and data science; CSU Fullerton BS</a:t>
             </a:r>
           </a:p>
           <a:p>
@@ -6720,7 +6720,7 @@
                 </a:solidFill>
                 <a:latin typeface="Calibri"/>
               </a:rPr>
-              <a:t>•  Certified PostgreSQL / SQL Server / MySQL DBA; Sage, QuickBooks, MS NAV</a:t>
+              <a:t>•  AWS Certified Developer; Databricks; Blockchain Training Alliance; Microsoft Certified Trainer</a:t>
             </a:r>
           </a:p>
           <a:p>
@@ -6736,7 +6736,23 @@
                 </a:solidFill>
                 <a:latin typeface="Calibri"/>
               </a:rPr>
-              <a:t>•  35 years real-estate investor, $10M+ portfolio; financial-industry data scientist; built v2.0</a:t>
+              <a:t>•  Certified PostgreSQL / SQL Server / MySQL DBA; Sage, QuickBooks, MS NAV</a:t>
+            </a:r>
+          </a:p>
+          <a:p>
+            <a:pPr>
+              <a:spcAft>
+                <a:spcPts val="300"/>
+              </a:spcAft>
+            </a:pPr>
+            <a:r>
+              <a:rPr sz="1000">
+                <a:solidFill>
+                  <a:srgbClr val="555F6B"/>
+                </a:solidFill>
+                <a:latin typeface="Calibri"/>
+              </a:rPr>
+              <a:t>•  35 years real-estate investor, $10M+ portfolio; built v2.0</a:t>
             </a:r>
           </a:p>
           <a:p>

</xml_diff>

<commit_message>
team: Dr Van Wilson bio (20+ years finance data science, secret clearance at the SEC and Fannie Mae, COVID mortgage-payment forecasting model, MIT)
Co-Authored-By: Claude Fable 5.1 <noreply@anthropic.com>
Claude-Session: https://claude.ai/code/session_01YTq7uaMnXTpa318aSx8TXi
</commit_message>
<xml_diff>
--- a/docs/grant-deck-2026-09-10.pptx
+++ b/docs/grant-deck-2026-09-10.pptx
@@ -6688,7 +6688,7 @@
                 </a:solidFill>
                 <a:latin typeface="Calibri"/>
               </a:rPr>
-              <a:t>•  Formerly U.S. Securities and Exchange Commission (SEC) and Fannie Mae</a:t>
+              <a:t>•  20+ years in data science, mostly in finance; secret clearance while at the U.S. SEC and Fannie Mae</a:t>
             </a:r>
           </a:p>
           <a:p>
@@ -6704,7 +6704,7 @@
                 </a:solidFill>
                 <a:latin typeface="Calibri"/>
               </a:rPr>
-              <a:t>•  MIT post-graduate program, AI and data science; CSU Fullerton BS</a:t>
+              <a:t>•  Fannie Mae: built the ML model forecasting mortgage payments after the COVID payment freeze</a:t>
             </a:r>
           </a:p>
           <a:p>
@@ -6720,7 +6720,7 @@
                 </a:solidFill>
                 <a:latin typeface="Calibri"/>
               </a:rPr>
-              <a:t>•  AWS Certified Developer; Databricks; Blockchain Training Alliance; Microsoft Certified Trainer</a:t>
+              <a:t>•  MIT post-graduate program, AI and data science; CSU Fullerton BS; AWS, Databricks, Blockchain Training Alliance, Microsoft Certified Trainer</a:t>
             </a:r>
           </a:p>
           <a:p>
@@ -6736,39 +6736,7 @@
                 </a:solidFill>
                 <a:latin typeface="Calibri"/>
               </a:rPr>
-              <a:t>•  Certified PostgreSQL / SQL Server / MySQL DBA; Sage, QuickBooks, MS NAV</a:t>
-            </a:r>
-          </a:p>
-          <a:p>
-            <a:pPr>
-              <a:spcAft>
-                <a:spcPts val="300"/>
-              </a:spcAft>
-            </a:pPr>
-            <a:r>
-              <a:rPr sz="1000">
-                <a:solidFill>
-                  <a:srgbClr val="555F6B"/>
-                </a:solidFill>
-                <a:latin typeface="Calibri"/>
-              </a:rPr>
-              <a:t>•  35 years real-estate investor, $10M+ portfolio; built v2.0</a:t>
-            </a:r>
-          </a:p>
-          <a:p>
-            <a:pPr>
-              <a:spcAft>
-                <a:spcPts val="300"/>
-              </a:spcAft>
-            </a:pPr>
-            <a:r>
-              <a:rPr sz="1000">
-                <a:solidFill>
-                  <a:srgbClr val="555F6B"/>
-                </a:solidFill>
-                <a:latin typeface="Calibri"/>
-              </a:rPr>
-              <a:t>•  linkedin.com/in/drvanwilson</a:t>
+              <a:t>•  Real-estate investor since 1998, 120+ transactions, $10M+ portfolio; built v2.0 · linkedin.com/in/drvanwilson</a:t>
             </a:r>
           </a:p>
         </p:txBody>

</xml_diff>